<commit_message>
Grafana AAA dashbord as part of initial deploment and Prometheus connectivity
</commit_message>
<xml_diff>
--- a/docs/aaa-platform-presentation.pptx
+++ b/docs/aaa-platform-presentation.pptx
@@ -21896,7 +21896,7 @@
                   <a:srgbClr val="FFFFFF"/>
                 </a:solidFill>
               </a:rPr>
-              <a:t>RADIUS Authentication Flow</a:t>
+              <a:t>Radius Static IP assignment flow</a:t>
             </a:r>
           </a:p>
         </p:txBody>
@@ -21953,7 +21953,7 @@
           <p:nvPr/>
         </p:nvPicPr>
         <p:blipFill>
-          <a:blip r:embed="rId3"/>
+          <a:blip r:embed="rId4"/>
           <a:stretch>
             <a:fillRect/>
           </a:stretch>

</xml_diff>